<commit_message>
add demo video link to presentation and finalize submission
</commit_message>
<xml_diff>
--- a/HabitForge_Presentation.pptx
+++ b/HabitForge_Presentation.pptx
@@ -7499,6 +7499,12 @@
               <a:rPr lang="en" dirty="0"/>
               <a:t>Project Demo Video - </a:t>
             </a:r>
+            <a:r>
+              <a:rPr lang="en-IN" dirty="0">
+                <a:hlinkClick r:id="rId3"/>
+              </a:rPr>
+              <a:t>https://youtu.be/WKyi9r0OIFo</a:t>
+            </a:r>
             <a:endParaRPr lang="en-IN" dirty="0"/>
           </a:p>
           <a:p>
@@ -7529,7 +7535,7 @@
             </a:r>
             <a:r>
               <a:rPr lang="en-IN" dirty="0">
-                <a:hlinkClick r:id="rId3"/>
+                <a:hlinkClick r:id="rId4"/>
               </a:rPr>
               <a:t>https://github.com/aniketnandi/Habit-Forge</a:t>
             </a:r>
@@ -7563,7 +7569,7 @@
             </a:r>
             <a:r>
               <a:rPr lang="en-IN" dirty="0">
-                <a:hlinkClick r:id="rId4"/>
+                <a:hlinkClick r:id="rId5"/>
               </a:rPr>
               <a:t>https://habit-forge-frontend-fox4.onrender.com</a:t>
             </a:r>

</xml_diff>

<commit_message>
add passport authentication, login/register, update docs and presentation
</commit_message>
<xml_diff>
--- a/HabitForge_Presentation.pptx
+++ b/HabitForge_Presentation.pptx
@@ -5,7 +5,7 @@
     <p:sldMasterId id="2147483659" r:id="rId1"/>
   </p:sldMasterIdLst>
   <p:notesMasterIdLst>
-    <p:notesMasterId r:id="rId15"/>
+    <p:notesMasterId r:id="rId16"/>
   </p:notesMasterIdLst>
   <p:sldIdLst>
     <p:sldId id="256" r:id="rId2"/>
@@ -15,12 +15,13 @@
     <p:sldId id="266" r:id="rId6"/>
     <p:sldId id="267" r:id="rId7"/>
     <p:sldId id="268" r:id="rId8"/>
-    <p:sldId id="259" r:id="rId9"/>
-    <p:sldId id="264" r:id="rId10"/>
-    <p:sldId id="260" r:id="rId11"/>
-    <p:sldId id="261" r:id="rId12"/>
-    <p:sldId id="262" r:id="rId13"/>
-    <p:sldId id="263" r:id="rId14"/>
+    <p:sldId id="269" r:id="rId9"/>
+    <p:sldId id="259" r:id="rId10"/>
+    <p:sldId id="264" r:id="rId11"/>
+    <p:sldId id="260" r:id="rId12"/>
+    <p:sldId id="261" r:id="rId13"/>
+    <p:sldId id="262" r:id="rId14"/>
+    <p:sldId id="263" r:id="rId15"/>
   </p:sldIdLst>
   <p:sldSz cx="9144000" cy="5143500" type="screen16x9"/>
   <p:notesSz cx="6858000" cy="9144000"/>
@@ -811,6 +812,133 @@
   <p:cSld>
     <p:spTree>
       <p:nvGrpSpPr>
+        <p:cNvPr id="1" name="Shape 69">
+          <a:extLst>
+            <a:ext uri="{FF2B5EF4-FFF2-40B4-BE49-F238E27FC236}">
+              <a16:creationId xmlns:a16="http://schemas.microsoft.com/office/drawing/2014/main" id="{7F2D1602-9942-F704-E77A-0426C4A91153}"/>
+            </a:ext>
+          </a:extLst>
+        </p:cNvPr>
+        <p:cNvGrpSpPr/>
+        <p:nvPr/>
+      </p:nvGrpSpPr>
+      <p:grpSpPr>
+        <a:xfrm>
+          <a:off x="0" y="0"/>
+          <a:ext cx="0" cy="0"/>
+          <a:chOff x="0" y="0"/>
+          <a:chExt cx="0" cy="0"/>
+        </a:xfrm>
+      </p:grpSpPr>
+      <p:sp>
+        <p:nvSpPr>
+          <p:cNvPr id="70" name="Google Shape;70;g4df5837ef2_0_5:notes">
+            <a:extLst>
+              <a:ext uri="{FF2B5EF4-FFF2-40B4-BE49-F238E27FC236}">
+                <a16:creationId xmlns:a16="http://schemas.microsoft.com/office/drawing/2014/main" id="{238033AF-B8DA-E33C-C80B-45F81AF9B0FE}"/>
+              </a:ext>
+            </a:extLst>
+          </p:cNvPr>
+          <p:cNvSpPr>
+            <a:spLocks noGrp="1" noRot="1" noChangeAspect="1"/>
+          </p:cNvSpPr>
+          <p:nvPr>
+            <p:ph type="sldImg" idx="2"/>
+          </p:nvPr>
+        </p:nvSpPr>
+        <p:spPr>
+          <a:xfrm>
+            <a:off x="381000" y="685800"/>
+            <a:ext cx="6096000" cy="3429000"/>
+          </a:xfrm>
+          <a:custGeom>
+            <a:avLst/>
+            <a:gdLst/>
+            <a:ahLst/>
+            <a:cxnLst/>
+            <a:rect l="l" t="t" r="r" b="b"/>
+            <a:pathLst>
+              <a:path w="120000" h="120000" extrusionOk="0">
+                <a:moveTo>
+                  <a:pt x="0" y="0"/>
+                </a:moveTo>
+                <a:lnTo>
+                  <a:pt x="120000" y="0"/>
+                </a:lnTo>
+                <a:lnTo>
+                  <a:pt x="120000" y="120000"/>
+                </a:lnTo>
+                <a:lnTo>
+                  <a:pt x="0" y="120000"/>
+                </a:lnTo>
+                <a:close/>
+              </a:path>
+            </a:pathLst>
+          </a:custGeom>
+        </p:spPr>
+      </p:sp>
+      <p:sp>
+        <p:nvSpPr>
+          <p:cNvPr id="71" name="Google Shape;71;g4df5837ef2_0_5:notes">
+            <a:extLst>
+              <a:ext uri="{FF2B5EF4-FFF2-40B4-BE49-F238E27FC236}">
+                <a16:creationId xmlns:a16="http://schemas.microsoft.com/office/drawing/2014/main" id="{906A643E-A51B-046F-BDAC-261D63AF9413}"/>
+              </a:ext>
+            </a:extLst>
+          </p:cNvPr>
+          <p:cNvSpPr txBox="1">
+            <a:spLocks noGrp="1"/>
+          </p:cNvSpPr>
+          <p:nvPr>
+            <p:ph type="body" idx="1"/>
+          </p:nvPr>
+        </p:nvSpPr>
+        <p:spPr>
+          <a:xfrm>
+            <a:off x="685800" y="4343400"/>
+            <a:ext cx="5486400" cy="4114800"/>
+          </a:xfrm>
+          <a:prstGeom prst="rect">
+            <a:avLst/>
+          </a:prstGeom>
+        </p:spPr>
+        <p:txBody>
+          <a:bodyPr spcFirstLastPara="1" wrap="square" lIns="91425" tIns="91425" rIns="91425" bIns="91425" anchor="t" anchorCtr="0">
+            <a:noAutofit/>
+          </a:bodyPr>
+          <a:lstStyle/>
+          <a:p>
+            <a:pPr marL="0" lvl="0" indent="0" algn="l" rtl="0">
+              <a:spcBef>
+                <a:spcPts val="0"/>
+              </a:spcBef>
+              <a:spcAft>
+                <a:spcPts val="0"/>
+              </a:spcAft>
+              <a:buNone/>
+            </a:pPr>
+            <a:endParaRPr/>
+          </a:p>
+        </p:txBody>
+      </p:sp>
+    </p:spTree>
+    <p:extLst>
+      <p:ext uri="{BB962C8B-B14F-4D97-AF65-F5344CB8AC3E}">
+        <p14:creationId xmlns:p14="http://schemas.microsoft.com/office/powerpoint/2010/main" val="4196729049"/>
+      </p:ext>
+    </p:extLst>
+  </p:cSld>
+  <p:clrMapOvr>
+    <a:masterClrMapping/>
+  </p:clrMapOvr>
+</p:notes>
+</file>
+
+<file path=ppt/notesSlides/notesSlide11.xml><?xml version="1.0" encoding="utf-8"?>
+<p:notes xmlns:a="http://schemas.openxmlformats.org/drawingml/2006/main" xmlns:r="http://schemas.openxmlformats.org/officeDocument/2006/relationships" xmlns:p="http://schemas.openxmlformats.org/presentationml/2006/main" showMasterSp="0" showMasterPhAnim="0">
+  <p:cSld>
+    <p:spTree>
+      <p:nvGrpSpPr>
         <p:cNvPr id="1" name="Shape 75"/>
         <p:cNvGrpSpPr/>
         <p:nvPr/>
@@ -910,7 +1038,7 @@
 </p:notes>
 </file>
 
-<file path=ppt/notesSlides/notesSlide11.xml><?xml version="1.0" encoding="utf-8"?>
+<file path=ppt/notesSlides/notesSlide12.xml><?xml version="1.0" encoding="utf-8"?>
 <p:notes xmlns:a="http://schemas.openxmlformats.org/drawingml/2006/main" xmlns:r="http://schemas.openxmlformats.org/officeDocument/2006/relationships" xmlns:p="http://schemas.openxmlformats.org/presentationml/2006/main" showMasterSp="0" showMasterPhAnim="0">
   <p:cSld>
     <p:spTree>
@@ -1014,7 +1142,7 @@
 </p:notes>
 </file>
 
-<file path=ppt/notesSlides/notesSlide12.xml><?xml version="1.0" encoding="utf-8"?>
+<file path=ppt/notesSlides/notesSlide13.xml><?xml version="1.0" encoding="utf-8"?>
 <p:notes xmlns:a="http://schemas.openxmlformats.org/drawingml/2006/main" xmlns:r="http://schemas.openxmlformats.org/officeDocument/2006/relationships" xmlns:p="http://schemas.openxmlformats.org/presentationml/2006/main" showMasterSp="0" showMasterPhAnim="0">
   <p:cSld>
     <p:spTree>
@@ -1118,7 +1246,7 @@
 </p:notes>
 </file>
 
-<file path=ppt/notesSlides/notesSlide13.xml><?xml version="1.0" encoding="utf-8"?>
+<file path=ppt/notesSlides/notesSlide14.xml><?xml version="1.0" encoding="utf-8"?>
 <p:notes xmlns:a="http://schemas.openxmlformats.org/drawingml/2006/main" xmlns:r="http://schemas.openxmlformats.org/officeDocument/2006/relationships" xmlns:p="http://schemas.openxmlformats.org/presentationml/2006/main" showMasterSp="0" showMasterPhAnim="0">
   <p:cSld>
     <p:spTree>
@@ -1943,6 +2071,133 @@
   <p:cSld>
     <p:spTree>
       <p:nvGrpSpPr>
+        <p:cNvPr id="1" name="Shape 64">
+          <a:extLst>
+            <a:ext uri="{FF2B5EF4-FFF2-40B4-BE49-F238E27FC236}">
+              <a16:creationId xmlns:a16="http://schemas.microsoft.com/office/drawing/2014/main" id="{7E0A5A64-2ABB-F407-0088-ED5CBDC9349A}"/>
+            </a:ext>
+          </a:extLst>
+        </p:cNvPr>
+        <p:cNvGrpSpPr/>
+        <p:nvPr/>
+      </p:nvGrpSpPr>
+      <p:grpSpPr>
+        <a:xfrm>
+          <a:off x="0" y="0"/>
+          <a:ext cx="0" cy="0"/>
+          <a:chOff x="0" y="0"/>
+          <a:chExt cx="0" cy="0"/>
+        </a:xfrm>
+      </p:grpSpPr>
+      <p:sp>
+        <p:nvSpPr>
+          <p:cNvPr id="65" name="Google Shape;65;g2824b25c245_0_0:notes">
+            <a:extLst>
+              <a:ext uri="{FF2B5EF4-FFF2-40B4-BE49-F238E27FC236}">
+                <a16:creationId xmlns:a16="http://schemas.microsoft.com/office/drawing/2014/main" id="{CAFC7E4A-8D52-9742-3BFE-8CEDD94D8826}"/>
+              </a:ext>
+            </a:extLst>
+          </p:cNvPr>
+          <p:cNvSpPr>
+            <a:spLocks noGrp="1" noRot="1" noChangeAspect="1"/>
+          </p:cNvSpPr>
+          <p:nvPr>
+            <p:ph type="sldImg" idx="2"/>
+          </p:nvPr>
+        </p:nvSpPr>
+        <p:spPr>
+          <a:xfrm>
+            <a:off x="381000" y="685800"/>
+            <a:ext cx="6096000" cy="3429000"/>
+          </a:xfrm>
+          <a:custGeom>
+            <a:avLst/>
+            <a:gdLst/>
+            <a:ahLst/>
+            <a:cxnLst/>
+            <a:rect l="l" t="t" r="r" b="b"/>
+            <a:pathLst>
+              <a:path w="120000" h="120000" extrusionOk="0">
+                <a:moveTo>
+                  <a:pt x="0" y="0"/>
+                </a:moveTo>
+                <a:lnTo>
+                  <a:pt x="120000" y="0"/>
+                </a:lnTo>
+                <a:lnTo>
+                  <a:pt x="120000" y="120000"/>
+                </a:lnTo>
+                <a:lnTo>
+                  <a:pt x="0" y="120000"/>
+                </a:lnTo>
+                <a:close/>
+              </a:path>
+            </a:pathLst>
+          </a:custGeom>
+        </p:spPr>
+      </p:sp>
+      <p:sp>
+        <p:nvSpPr>
+          <p:cNvPr id="66" name="Google Shape;66;g2824b25c245_0_0:notes">
+            <a:extLst>
+              <a:ext uri="{FF2B5EF4-FFF2-40B4-BE49-F238E27FC236}">
+                <a16:creationId xmlns:a16="http://schemas.microsoft.com/office/drawing/2014/main" id="{7E4BF911-D09B-7487-1086-41E777A530B3}"/>
+              </a:ext>
+            </a:extLst>
+          </p:cNvPr>
+          <p:cNvSpPr txBox="1">
+            <a:spLocks noGrp="1"/>
+          </p:cNvSpPr>
+          <p:nvPr>
+            <p:ph type="body" idx="1"/>
+          </p:nvPr>
+        </p:nvSpPr>
+        <p:spPr>
+          <a:xfrm>
+            <a:off x="685800" y="4343400"/>
+            <a:ext cx="5486400" cy="4114800"/>
+          </a:xfrm>
+          <a:prstGeom prst="rect">
+            <a:avLst/>
+          </a:prstGeom>
+        </p:spPr>
+        <p:txBody>
+          <a:bodyPr spcFirstLastPara="1" wrap="square" lIns="91425" tIns="91425" rIns="91425" bIns="91425" anchor="t" anchorCtr="0">
+            <a:noAutofit/>
+          </a:bodyPr>
+          <a:lstStyle/>
+          <a:p>
+            <a:pPr marL="0" lvl="0" indent="0" algn="l" rtl="0">
+              <a:spcBef>
+                <a:spcPts val="0"/>
+              </a:spcBef>
+              <a:spcAft>
+                <a:spcPts val="0"/>
+              </a:spcAft>
+              <a:buNone/>
+            </a:pPr>
+            <a:endParaRPr/>
+          </a:p>
+        </p:txBody>
+      </p:sp>
+    </p:spTree>
+    <p:extLst>
+      <p:ext uri="{BB962C8B-B14F-4D97-AF65-F5344CB8AC3E}">
+        <p14:creationId xmlns:p14="http://schemas.microsoft.com/office/powerpoint/2010/main" val="1863127657"/>
+      </p:ext>
+    </p:extLst>
+  </p:cSld>
+  <p:clrMapOvr>
+    <a:masterClrMapping/>
+  </p:clrMapOvr>
+</p:notes>
+</file>
+
+<file path=ppt/notesSlides/notesSlide9.xml><?xml version="1.0" encoding="utf-8"?>
+<p:notes xmlns:a="http://schemas.openxmlformats.org/drawingml/2006/main" xmlns:r="http://schemas.openxmlformats.org/officeDocument/2006/relationships" xmlns:p="http://schemas.openxmlformats.org/presentationml/2006/main" showMasterSp="0" showMasterPhAnim="0">
+  <p:cSld>
+    <p:spTree>
+      <p:nvGrpSpPr>
         <p:cNvPr id="1" name="Shape 69"/>
         <p:cNvGrpSpPr/>
         <p:nvPr/>
@@ -2035,133 +2290,6 @@
         </p:txBody>
       </p:sp>
     </p:spTree>
-  </p:cSld>
-  <p:clrMapOvr>
-    <a:masterClrMapping/>
-  </p:clrMapOvr>
-</p:notes>
-</file>
-
-<file path=ppt/notesSlides/notesSlide9.xml><?xml version="1.0" encoding="utf-8"?>
-<p:notes xmlns:a="http://schemas.openxmlformats.org/drawingml/2006/main" xmlns:r="http://schemas.openxmlformats.org/officeDocument/2006/relationships" xmlns:p="http://schemas.openxmlformats.org/presentationml/2006/main" showMasterSp="0" showMasterPhAnim="0">
-  <p:cSld>
-    <p:spTree>
-      <p:nvGrpSpPr>
-        <p:cNvPr id="1" name="Shape 69">
-          <a:extLst>
-            <a:ext uri="{FF2B5EF4-FFF2-40B4-BE49-F238E27FC236}">
-              <a16:creationId xmlns:a16="http://schemas.microsoft.com/office/drawing/2014/main" id="{7F2D1602-9942-F704-E77A-0426C4A91153}"/>
-            </a:ext>
-          </a:extLst>
-        </p:cNvPr>
-        <p:cNvGrpSpPr/>
-        <p:nvPr/>
-      </p:nvGrpSpPr>
-      <p:grpSpPr>
-        <a:xfrm>
-          <a:off x="0" y="0"/>
-          <a:ext cx="0" cy="0"/>
-          <a:chOff x="0" y="0"/>
-          <a:chExt cx="0" cy="0"/>
-        </a:xfrm>
-      </p:grpSpPr>
-      <p:sp>
-        <p:nvSpPr>
-          <p:cNvPr id="70" name="Google Shape;70;g4df5837ef2_0_5:notes">
-            <a:extLst>
-              <a:ext uri="{FF2B5EF4-FFF2-40B4-BE49-F238E27FC236}">
-                <a16:creationId xmlns:a16="http://schemas.microsoft.com/office/drawing/2014/main" id="{238033AF-B8DA-E33C-C80B-45F81AF9B0FE}"/>
-              </a:ext>
-            </a:extLst>
-          </p:cNvPr>
-          <p:cNvSpPr>
-            <a:spLocks noGrp="1" noRot="1" noChangeAspect="1"/>
-          </p:cNvSpPr>
-          <p:nvPr>
-            <p:ph type="sldImg" idx="2"/>
-          </p:nvPr>
-        </p:nvSpPr>
-        <p:spPr>
-          <a:xfrm>
-            <a:off x="381000" y="685800"/>
-            <a:ext cx="6096000" cy="3429000"/>
-          </a:xfrm>
-          <a:custGeom>
-            <a:avLst/>
-            <a:gdLst/>
-            <a:ahLst/>
-            <a:cxnLst/>
-            <a:rect l="l" t="t" r="r" b="b"/>
-            <a:pathLst>
-              <a:path w="120000" h="120000" extrusionOk="0">
-                <a:moveTo>
-                  <a:pt x="0" y="0"/>
-                </a:moveTo>
-                <a:lnTo>
-                  <a:pt x="120000" y="0"/>
-                </a:lnTo>
-                <a:lnTo>
-                  <a:pt x="120000" y="120000"/>
-                </a:lnTo>
-                <a:lnTo>
-                  <a:pt x="0" y="120000"/>
-                </a:lnTo>
-                <a:close/>
-              </a:path>
-            </a:pathLst>
-          </a:custGeom>
-        </p:spPr>
-      </p:sp>
-      <p:sp>
-        <p:nvSpPr>
-          <p:cNvPr id="71" name="Google Shape;71;g4df5837ef2_0_5:notes">
-            <a:extLst>
-              <a:ext uri="{FF2B5EF4-FFF2-40B4-BE49-F238E27FC236}">
-                <a16:creationId xmlns:a16="http://schemas.microsoft.com/office/drawing/2014/main" id="{906A643E-A51B-046F-BDAC-261D63AF9413}"/>
-              </a:ext>
-            </a:extLst>
-          </p:cNvPr>
-          <p:cNvSpPr txBox="1">
-            <a:spLocks noGrp="1"/>
-          </p:cNvSpPr>
-          <p:nvPr>
-            <p:ph type="body" idx="1"/>
-          </p:nvPr>
-        </p:nvSpPr>
-        <p:spPr>
-          <a:xfrm>
-            <a:off x="685800" y="4343400"/>
-            <a:ext cx="5486400" cy="4114800"/>
-          </a:xfrm>
-          <a:prstGeom prst="rect">
-            <a:avLst/>
-          </a:prstGeom>
-        </p:spPr>
-        <p:txBody>
-          <a:bodyPr spcFirstLastPara="1" wrap="square" lIns="91425" tIns="91425" rIns="91425" bIns="91425" anchor="t" anchorCtr="0">
-            <a:noAutofit/>
-          </a:bodyPr>
-          <a:lstStyle/>
-          <a:p>
-            <a:pPr marL="0" lvl="0" indent="0" algn="l" rtl="0">
-              <a:spcBef>
-                <a:spcPts val="0"/>
-              </a:spcBef>
-              <a:spcAft>
-                <a:spcPts val="0"/>
-              </a:spcAft>
-              <a:buNone/>
-            </a:pPr>
-            <a:endParaRPr/>
-          </a:p>
-        </p:txBody>
-      </p:sp>
-    </p:spTree>
-    <p:extLst>
-      <p:ext uri="{BB962C8B-B14F-4D97-AF65-F5344CB8AC3E}">
-        <p14:creationId xmlns:p14="http://schemas.microsoft.com/office/powerpoint/2010/main" val="4196729049"/>
-      </p:ext>
-    </p:extLst>
   </p:cSld>
   <p:clrMapOvr>
     <a:masterClrMapping/>
@@ -7104,6 +7232,190 @@
   <p:cSld>
     <p:spTree>
       <p:nvGrpSpPr>
+        <p:cNvPr id="1" name="Shape 72">
+          <a:extLst>
+            <a:ext uri="{FF2B5EF4-FFF2-40B4-BE49-F238E27FC236}">
+              <a16:creationId xmlns:a16="http://schemas.microsoft.com/office/drawing/2014/main" id="{3483CE52-5F58-2B5C-1F57-63F356C8C09D}"/>
+            </a:ext>
+          </a:extLst>
+        </p:cNvPr>
+        <p:cNvGrpSpPr/>
+        <p:nvPr/>
+      </p:nvGrpSpPr>
+      <p:grpSpPr>
+        <a:xfrm>
+          <a:off x="0" y="0"/>
+          <a:ext cx="0" cy="0"/>
+          <a:chOff x="0" y="0"/>
+          <a:chExt cx="0" cy="0"/>
+        </a:xfrm>
+      </p:grpSpPr>
+      <p:sp>
+        <p:nvSpPr>
+          <p:cNvPr id="73" name="Google Shape;73;p16">
+            <a:extLst>
+              <a:ext uri="{FF2B5EF4-FFF2-40B4-BE49-F238E27FC236}">
+                <a16:creationId xmlns:a16="http://schemas.microsoft.com/office/drawing/2014/main" id="{0AA5E858-CD0C-6F3C-99DE-7C2DA183AFA4}"/>
+              </a:ext>
+            </a:extLst>
+          </p:cNvPr>
+          <p:cNvSpPr txBox="1">
+            <a:spLocks noGrp="1"/>
+          </p:cNvSpPr>
+          <p:nvPr>
+            <p:ph type="title"/>
+          </p:nvPr>
+        </p:nvSpPr>
+        <p:spPr>
+          <a:xfrm>
+            <a:off x="311700" y="445025"/>
+            <a:ext cx="8520600" cy="572700"/>
+          </a:xfrm>
+          <a:prstGeom prst="rect">
+            <a:avLst/>
+          </a:prstGeom>
+        </p:spPr>
+        <p:txBody>
+          <a:bodyPr spcFirstLastPara="1" wrap="square" lIns="91425" tIns="91425" rIns="91425" bIns="91425" anchor="t" anchorCtr="0">
+            <a:noAutofit/>
+          </a:bodyPr>
+          <a:lstStyle/>
+          <a:p>
+            <a:pPr marL="0" lvl="0" indent="0" algn="l" rtl="0">
+              <a:spcBef>
+                <a:spcPts val="0"/>
+              </a:spcBef>
+              <a:spcAft>
+                <a:spcPts val="0"/>
+              </a:spcAft>
+              <a:buNone/>
+            </a:pPr>
+            <a:r>
+              <a:rPr lang="en-US" dirty="0"/>
+              <a:t>What Makes This Project Different?</a:t>
+            </a:r>
+            <a:endParaRPr dirty="0"/>
+          </a:p>
+        </p:txBody>
+      </p:sp>
+      <p:sp>
+        <p:nvSpPr>
+          <p:cNvPr id="74" name="Google Shape;74;p16">
+            <a:extLst>
+              <a:ext uri="{FF2B5EF4-FFF2-40B4-BE49-F238E27FC236}">
+                <a16:creationId xmlns:a16="http://schemas.microsoft.com/office/drawing/2014/main" id="{85CC995F-BB81-4BC6-9A27-DF1F2A5FFEE0}"/>
+              </a:ext>
+            </a:extLst>
+          </p:cNvPr>
+          <p:cNvSpPr txBox="1">
+            <a:spLocks noGrp="1"/>
+          </p:cNvSpPr>
+          <p:nvPr>
+            <p:ph type="body" idx="1"/>
+          </p:nvPr>
+        </p:nvSpPr>
+        <p:spPr>
+          <a:xfrm>
+            <a:off x="311700" y="1152475"/>
+            <a:ext cx="8520600" cy="3416400"/>
+          </a:xfrm>
+          <a:prstGeom prst="rect">
+            <a:avLst/>
+          </a:prstGeom>
+        </p:spPr>
+        <p:txBody>
+          <a:bodyPr spcFirstLastPara="1" wrap="square" lIns="91425" tIns="91425" rIns="91425" bIns="91425" anchor="t" anchorCtr="0">
+            <a:noAutofit/>
+          </a:bodyPr>
+          <a:lstStyle/>
+          <a:p>
+            <a:pPr marL="0" lvl="0" indent="0" algn="l" rtl="0">
+              <a:spcBef>
+                <a:spcPts val="0"/>
+              </a:spcBef>
+              <a:spcAft>
+                <a:spcPts val="1600"/>
+              </a:spcAft>
+              <a:buNone/>
+            </a:pPr>
+            <a:r>
+              <a:rPr lang="en-US" dirty="0"/>
+              <a:t>Full analytics engine with streak calculation, weekly completion %, and date range filtering</a:t>
+            </a:r>
+          </a:p>
+          <a:p>
+            <a:pPr marL="0" lvl="0" indent="0" algn="l" rtl="0">
+              <a:spcBef>
+                <a:spcPts val="0"/>
+              </a:spcBef>
+              <a:spcAft>
+                <a:spcPts val="1600"/>
+              </a:spcAft>
+              <a:buNone/>
+            </a:pPr>
+            <a:r>
+              <a:rPr lang="en-US" dirty="0"/>
+              <a:t>3 MongoDB collections with full CRUD split between both team members</a:t>
+            </a:r>
+          </a:p>
+          <a:p>
+            <a:pPr marL="0" lvl="0" indent="0" algn="l" rtl="0">
+              <a:spcBef>
+                <a:spcPts val="0"/>
+              </a:spcBef>
+              <a:spcAft>
+                <a:spcPts val="1600"/>
+              </a:spcAft>
+              <a:buNone/>
+            </a:pPr>
+            <a:r>
+              <a:rPr lang="en-US" dirty="0"/>
+              <a:t>2046 synthetic records with realistic streak patterns, duplicate prevention and batch seeding</a:t>
+            </a:r>
+          </a:p>
+          <a:p>
+            <a:pPr marL="0" lvl="0" indent="0" algn="l" rtl="0">
+              <a:spcBef>
+                <a:spcPts val="0"/>
+              </a:spcBef>
+              <a:spcAft>
+                <a:spcPts val="1600"/>
+              </a:spcAft>
+              <a:buNone/>
+            </a:pPr>
+            <a:r>
+              <a:rPr lang="en-US" dirty="0"/>
+              <a:t>Per-user data isolation - each user only sees their own habits, logs, and goals via Passport session auth (except </a:t>
+            </a:r>
+            <a:r>
+              <a:rPr lang="en-US" dirty="0" err="1"/>
+              <a:t>testuser</a:t>
+            </a:r>
+            <a:r>
+              <a:rPr lang="en-US" dirty="0"/>
+              <a:t> which has all 1000+ seeded data)</a:t>
+            </a:r>
+          </a:p>
+        </p:txBody>
+      </p:sp>
+    </p:spTree>
+    <p:extLst>
+      <p:ext uri="{BB962C8B-B14F-4D97-AF65-F5344CB8AC3E}">
+        <p14:creationId xmlns:p14="http://schemas.microsoft.com/office/powerpoint/2010/main" val="490821702"/>
+      </p:ext>
+    </p:extLst>
+  </p:cSld>
+  <p:clrMapOvr>
+    <a:masterClrMapping/>
+  </p:clrMapOvr>
+</p:sld>
+</file>
+
+<file path=ppt/slides/slide11.xml><?xml version="1.0" encoding="utf-8"?>
+<p:sld xmlns:a="http://schemas.openxmlformats.org/drawingml/2006/main" xmlns:r="http://schemas.openxmlformats.org/officeDocument/2006/relationships" xmlns:p="http://schemas.openxmlformats.org/presentationml/2006/main">
+  <p:cSld>
+    <p:spTree>
+      <p:nvGrpSpPr>
         <p:cNvPr id="1" name="Shape 78"/>
         <p:cNvGrpSpPr/>
         <p:nvPr/>
@@ -7170,8 +7482,8 @@
         </p:nvSpPr>
         <p:spPr>
           <a:xfrm>
-            <a:off x="311700" y="1152475"/>
-            <a:ext cx="8520600" cy="3416400"/>
+            <a:off x="311700" y="1003794"/>
+            <a:ext cx="8520600" cy="3991025"/>
           </a:xfrm>
           <a:prstGeom prst="rect">
             <a:avLst/>
@@ -7242,6 +7554,29 @@
               <a:t>Realistic seed data with 2046 logs, streak patterns, duplicate prevention, and MongoDB indexes</a:t>
             </a:r>
           </a:p>
+          <a:p>
+            <a:pPr marL="0" lvl="0" indent="0" algn="l" rtl="0">
+              <a:spcBef>
+                <a:spcPts val="0"/>
+              </a:spcBef>
+              <a:spcAft>
+                <a:spcPts val="1600"/>
+              </a:spcAft>
+              <a:buNone/>
+            </a:pPr>
+            <a:r>
+              <a:rPr lang="en-US" dirty="0"/>
+              <a:t>Full Passport.js authentication with session cookies, </a:t>
+            </a:r>
+            <a:r>
+              <a:rPr lang="en-US" dirty="0" err="1"/>
+              <a:t>bcrypt</a:t>
+            </a:r>
+            <a:r>
+              <a:rPr lang="en-US" dirty="0"/>
+              <a:t> password hashing, and protected API routes</a:t>
+            </a:r>
+          </a:p>
         </p:txBody>
       </p:sp>
     </p:spTree>
@@ -7252,7 +7587,7 @@
 </p:sld>
 </file>
 
-<file path=ppt/slides/slide11.xml><?xml version="1.0" encoding="utf-8"?>
+<file path=ppt/slides/slide12.xml><?xml version="1.0" encoding="utf-8"?>
 <p:sld xmlns:a="http://schemas.openxmlformats.org/drawingml/2006/main" xmlns:r="http://schemas.openxmlformats.org/officeDocument/2006/relationships" xmlns:p="http://schemas.openxmlformats.org/presentationml/2006/main">
   <p:cSld>
     <p:spTree>
@@ -7392,6 +7727,21 @@
               <a:t>Merge conflicts from coordinating commits between team members across different machines</a:t>
             </a:r>
           </a:p>
+          <a:p>
+            <a:pPr marL="0" lvl="0" indent="0" algn="l" rtl="0">
+              <a:spcBef>
+                <a:spcPts val="0"/>
+              </a:spcBef>
+              <a:spcAft>
+                <a:spcPts val="1600"/>
+              </a:spcAft>
+              <a:buNone/>
+            </a:pPr>
+            <a:r>
+              <a:rPr lang="en-US" dirty="0"/>
+              <a:t>Implementing Passport local strategy with session cookies across separate frontend and backend deployments on Render</a:t>
+            </a:r>
+          </a:p>
         </p:txBody>
       </p:sp>
     </p:spTree>
@@ -7402,7 +7752,7 @@
 </p:sld>
 </file>
 
-<file path=ppt/slides/slide12.xml><?xml version="1.0" encoding="utf-8"?>
+<file path=ppt/slides/slide13.xml><?xml version="1.0" encoding="utf-8"?>
 <p:sld xmlns:a="http://schemas.openxmlformats.org/drawingml/2006/main" xmlns:r="http://schemas.openxmlformats.org/officeDocument/2006/relationships" xmlns:p="http://schemas.openxmlformats.org/presentationml/2006/main">
   <p:cSld>
     <p:spTree>
@@ -7503,7 +7853,7 @@
               <a:rPr lang="en-IN" dirty="0">
                 <a:hlinkClick r:id="rId3"/>
               </a:rPr>
-              <a:t>https://youtu.be/WKyi9r0OIFo</a:t>
+              <a:t>https://youtu.be/vYcBYF3roz8</a:t>
             </a:r>
             <a:endParaRPr lang="en-IN" dirty="0"/>
           </a:p>
@@ -7597,7 +7947,7 @@
 </p:sld>
 </file>
 
-<file path=ppt/slides/slide13.xml><?xml version="1.0" encoding="utf-8"?>
+<file path=ppt/slides/slide14.xml><?xml version="1.0" encoding="utf-8"?>
 <p:sld xmlns:a="http://schemas.openxmlformats.org/drawingml/2006/main" xmlns:r="http://schemas.openxmlformats.org/officeDocument/2006/relationships" xmlns:p="http://schemas.openxmlformats.org/presentationml/2006/main">
   <p:cSld>
     <p:spTree>
@@ -7874,6 +8224,22 @@
               <a:t>Support analytics with sort, filter by date range, and personal weekly goal targets</a:t>
             </a:r>
           </a:p>
+          <a:p>
+            <a:pPr marL="457200" lvl="0" indent="-342900" algn="l" rtl="0">
+              <a:spcBef>
+                <a:spcPts val="0"/>
+              </a:spcBef>
+              <a:spcAft>
+                <a:spcPts val="0"/>
+              </a:spcAft>
+              <a:buSzPts val="1800"/>
+              <a:buChar char="●"/>
+            </a:pPr>
+            <a:r>
+              <a:rPr lang="en-US" dirty="0"/>
+              <a:t>Support user authentication with register and login so each user's habits are private</a:t>
+            </a:r>
+          </a:p>
         </p:txBody>
       </p:sp>
     </p:spTree>
@@ -8002,7 +8368,7 @@
             </a:pPr>
             <a:r>
               <a:rPr lang="en-US" dirty="0"/>
-              <a:t>Wireframes focused on habit cards, log history, and analytics progress bars</a:t>
+              <a:t>Mockups focused on habit cards, log history, and analytics progress bars</a:t>
             </a:r>
           </a:p>
           <a:p>
@@ -8038,10 +8404,10 @@
       </p:sp>
       <p:pic>
         <p:nvPicPr>
-          <p:cNvPr id="4" name="Picture 3">
+          <p:cNvPr id="5" name="Picture 4">
             <a:extLst>
               <a:ext uri="{FF2B5EF4-FFF2-40B4-BE49-F238E27FC236}">
-                <a16:creationId xmlns:a16="http://schemas.microsoft.com/office/drawing/2014/main" id="{89F1F012-228D-0A26-ECA9-D2058D3662D5}"/>
+                <a16:creationId xmlns:a16="http://schemas.microsoft.com/office/drawing/2014/main" id="{389724CB-A395-9695-83C1-7D64B2B5753B}"/>
               </a:ext>
             </a:extLst>
           </p:cNvPr>
@@ -8058,8 +8424,8 @@
         </p:blipFill>
         <p:spPr>
           <a:xfrm>
-            <a:off x="1228258" y="3053510"/>
-            <a:ext cx="6687483" cy="924054"/>
+            <a:off x="994863" y="2968834"/>
+            <a:ext cx="7154273" cy="885949"/>
           </a:xfrm>
           <a:prstGeom prst="rect">
             <a:avLst/>
@@ -8535,6 +8901,150 @@
   <p:cSld>
     <p:spTree>
       <p:nvGrpSpPr>
+        <p:cNvPr id="1" name="Shape 67">
+          <a:extLst>
+            <a:ext uri="{FF2B5EF4-FFF2-40B4-BE49-F238E27FC236}">
+              <a16:creationId xmlns:a16="http://schemas.microsoft.com/office/drawing/2014/main" id="{60BDBCAA-92D8-943B-C616-06D0E8FA9A3D}"/>
+            </a:ext>
+          </a:extLst>
+        </p:cNvPr>
+        <p:cNvGrpSpPr/>
+        <p:nvPr/>
+      </p:nvGrpSpPr>
+      <p:grpSpPr>
+        <a:xfrm>
+          <a:off x="0" y="0"/>
+          <a:ext cx="0" cy="0"/>
+          <a:chOff x="0" y="0"/>
+          <a:chExt cx="0" cy="0"/>
+        </a:xfrm>
+      </p:grpSpPr>
+      <p:sp>
+        <p:nvSpPr>
+          <p:cNvPr id="68" name="Google Shape;68;p15">
+            <a:extLst>
+              <a:ext uri="{FF2B5EF4-FFF2-40B4-BE49-F238E27FC236}">
+                <a16:creationId xmlns:a16="http://schemas.microsoft.com/office/drawing/2014/main" id="{5648964D-2377-2937-C9EE-7A1E58809156}"/>
+              </a:ext>
+            </a:extLst>
+          </p:cNvPr>
+          <p:cNvSpPr txBox="1">
+            <a:spLocks noGrp="1"/>
+          </p:cNvSpPr>
+          <p:nvPr>
+            <p:ph type="title"/>
+          </p:nvPr>
+        </p:nvSpPr>
+        <p:spPr>
+          <a:xfrm>
+            <a:off x="311700" y="445025"/>
+            <a:ext cx="8520600" cy="572700"/>
+          </a:xfrm>
+          <a:prstGeom prst="rect">
+            <a:avLst/>
+          </a:prstGeom>
+        </p:spPr>
+        <p:txBody>
+          <a:bodyPr spcFirstLastPara="1" wrap="square" lIns="91425" tIns="91425" rIns="91425" bIns="91425" anchor="t" anchorCtr="0">
+            <a:noAutofit/>
+          </a:bodyPr>
+          <a:lstStyle/>
+          <a:p>
+            <a:pPr marL="0" lvl="0" indent="0" algn="l" rtl="0">
+              <a:spcBef>
+                <a:spcPts val="0"/>
+              </a:spcBef>
+              <a:spcAft>
+                <a:spcPts val="0"/>
+              </a:spcAft>
+              <a:buNone/>
+            </a:pPr>
+            <a:r>
+              <a:rPr lang="en"/>
+              <a:t>Design and Mockups</a:t>
+            </a:r>
+            <a:endParaRPr/>
+          </a:p>
+        </p:txBody>
+      </p:sp>
+      <p:pic>
+        <p:nvPicPr>
+          <p:cNvPr id="3" name="Picture 2">
+            <a:extLst>
+              <a:ext uri="{FF2B5EF4-FFF2-40B4-BE49-F238E27FC236}">
+                <a16:creationId xmlns:a16="http://schemas.microsoft.com/office/drawing/2014/main" id="{780A6669-3E3C-DBA3-FF79-FCAC963350E9}"/>
+              </a:ext>
+            </a:extLst>
+          </p:cNvPr>
+          <p:cNvPicPr>
+            <a:picLocks noChangeAspect="1"/>
+          </p:cNvPicPr>
+          <p:nvPr/>
+        </p:nvPicPr>
+        <p:blipFill>
+          <a:blip r:embed="rId3"/>
+          <a:stretch>
+            <a:fillRect/>
+          </a:stretch>
+        </p:blipFill>
+        <p:spPr>
+          <a:xfrm>
+            <a:off x="926746" y="1017725"/>
+            <a:ext cx="3645254" cy="3990594"/>
+          </a:xfrm>
+          <a:prstGeom prst="rect">
+            <a:avLst/>
+          </a:prstGeom>
+        </p:spPr>
+      </p:pic>
+      <p:pic>
+        <p:nvPicPr>
+          <p:cNvPr id="6" name="Picture 5">
+            <a:extLst>
+              <a:ext uri="{FF2B5EF4-FFF2-40B4-BE49-F238E27FC236}">
+                <a16:creationId xmlns:a16="http://schemas.microsoft.com/office/drawing/2014/main" id="{CBA91ECA-AE3F-2A29-2198-80A3967F33E4}"/>
+              </a:ext>
+            </a:extLst>
+          </p:cNvPr>
+          <p:cNvPicPr>
+            <a:picLocks noChangeAspect="1"/>
+          </p:cNvPicPr>
+          <p:nvPr/>
+        </p:nvPicPr>
+        <p:blipFill>
+          <a:blip r:embed="rId4"/>
+          <a:stretch>
+            <a:fillRect/>
+          </a:stretch>
+        </p:blipFill>
+        <p:spPr>
+          <a:xfrm>
+            <a:off x="4641203" y="997014"/>
+            <a:ext cx="3645254" cy="4011305"/>
+          </a:xfrm>
+          <a:prstGeom prst="rect">
+            <a:avLst/>
+          </a:prstGeom>
+        </p:spPr>
+      </p:pic>
+    </p:spTree>
+    <p:extLst>
+      <p:ext uri="{BB962C8B-B14F-4D97-AF65-F5344CB8AC3E}">
+        <p14:creationId xmlns:p14="http://schemas.microsoft.com/office/powerpoint/2010/main" val="3965327481"/>
+      </p:ext>
+    </p:extLst>
+  </p:cSld>
+  <p:clrMapOvr>
+    <a:masterClrMapping/>
+  </p:clrMapOvr>
+</p:sld>
+</file>
+
+<file path=ppt/slides/slide9.xml><?xml version="1.0" encoding="utf-8"?>
+<p:sld xmlns:a="http://schemas.openxmlformats.org/drawingml/2006/main" xmlns:r="http://schemas.openxmlformats.org/officeDocument/2006/relationships" xmlns:p="http://schemas.openxmlformats.org/presentationml/2006/main">
+  <p:cSld>
+    <p:spTree>
+      <p:nvGrpSpPr>
         <p:cNvPr id="1" name="Shape 72"/>
         <p:cNvGrpSpPr/>
         <p:nvPr/>
@@ -8640,7 +9150,7 @@
             </a:pPr>
             <a:r>
               <a:rPr lang="en-IN" dirty="0"/>
-              <a:t>MongoDB native driver (3 collections: habits, logs, goals)</a:t>
+              <a:t>MongoDB native driver (4 collections: habits, logs, goals, users)</a:t>
             </a:r>
           </a:p>
           <a:p>
@@ -8655,15 +9165,15 @@
             </a:pPr>
             <a:r>
               <a:rPr lang="en-IN" dirty="0"/>
-              <a:t>React 18 with </a:t>
+              <a:t>React 18 </a:t>
             </a:r>
             <a:r>
-              <a:rPr lang="en-IN" dirty="0" err="1"/>
-              <a:t>Hools</a:t>
+              <a:rPr lang="en-IN"/>
+              <a:t>with Hooks </a:t>
             </a:r>
             <a:r>
               <a:rPr lang="en-IN" dirty="0"/>
-              <a:t> + React Router v6 (client-side rendering)</a:t>
+              <a:t>+ React Router v6 (client-side rendering)</a:t>
             </a:r>
           </a:p>
           <a:p>
@@ -8704,172 +9214,34 @@
               <a:rPr lang="en-IN" dirty="0"/>
               <a:t>Deployed on Render (backend Web Service + frontend Static Site)</a:t>
             </a:r>
+          </a:p>
+          <a:p>
+            <a:pPr marL="0" lvl="0" indent="0" algn="l" rtl="0">
+              <a:spcBef>
+                <a:spcPts val="0"/>
+              </a:spcBef>
+              <a:spcAft>
+                <a:spcPts val="1600"/>
+              </a:spcAft>
+              <a:buNone/>
+            </a:pPr>
+            <a:r>
+              <a:rPr lang="en-IN" dirty="0"/>
+              <a:t>Passport.js + </a:t>
+            </a:r>
+            <a:r>
+              <a:rPr lang="en-IN" dirty="0" err="1"/>
+              <a:t>bcrypt</a:t>
+            </a:r>
+            <a:r>
+              <a:rPr lang="en-IN" dirty="0"/>
+              <a:t> + express-session (authentication)</a:t>
+            </a:r>
             <a:endParaRPr dirty="0"/>
           </a:p>
         </p:txBody>
       </p:sp>
     </p:spTree>
-  </p:cSld>
-  <p:clrMapOvr>
-    <a:masterClrMapping/>
-  </p:clrMapOvr>
-</p:sld>
-</file>
-
-<file path=ppt/slides/slide9.xml><?xml version="1.0" encoding="utf-8"?>
-<p:sld xmlns:a="http://schemas.openxmlformats.org/drawingml/2006/main" xmlns:r="http://schemas.openxmlformats.org/officeDocument/2006/relationships" xmlns:p="http://schemas.openxmlformats.org/presentationml/2006/main">
-  <p:cSld>
-    <p:spTree>
-      <p:nvGrpSpPr>
-        <p:cNvPr id="1" name="Shape 72">
-          <a:extLst>
-            <a:ext uri="{FF2B5EF4-FFF2-40B4-BE49-F238E27FC236}">
-              <a16:creationId xmlns:a16="http://schemas.microsoft.com/office/drawing/2014/main" id="{3483CE52-5F58-2B5C-1F57-63F356C8C09D}"/>
-            </a:ext>
-          </a:extLst>
-        </p:cNvPr>
-        <p:cNvGrpSpPr/>
-        <p:nvPr/>
-      </p:nvGrpSpPr>
-      <p:grpSpPr>
-        <a:xfrm>
-          <a:off x="0" y="0"/>
-          <a:ext cx="0" cy="0"/>
-          <a:chOff x="0" y="0"/>
-          <a:chExt cx="0" cy="0"/>
-        </a:xfrm>
-      </p:grpSpPr>
-      <p:sp>
-        <p:nvSpPr>
-          <p:cNvPr id="73" name="Google Shape;73;p16">
-            <a:extLst>
-              <a:ext uri="{FF2B5EF4-FFF2-40B4-BE49-F238E27FC236}">
-                <a16:creationId xmlns:a16="http://schemas.microsoft.com/office/drawing/2014/main" id="{0AA5E858-CD0C-6F3C-99DE-7C2DA183AFA4}"/>
-              </a:ext>
-            </a:extLst>
-          </p:cNvPr>
-          <p:cNvSpPr txBox="1">
-            <a:spLocks noGrp="1"/>
-          </p:cNvSpPr>
-          <p:nvPr>
-            <p:ph type="title"/>
-          </p:nvPr>
-        </p:nvSpPr>
-        <p:spPr>
-          <a:xfrm>
-            <a:off x="311700" y="445025"/>
-            <a:ext cx="8520600" cy="572700"/>
-          </a:xfrm>
-          <a:prstGeom prst="rect">
-            <a:avLst/>
-          </a:prstGeom>
-        </p:spPr>
-        <p:txBody>
-          <a:bodyPr spcFirstLastPara="1" wrap="square" lIns="91425" tIns="91425" rIns="91425" bIns="91425" anchor="t" anchorCtr="0">
-            <a:noAutofit/>
-          </a:bodyPr>
-          <a:lstStyle/>
-          <a:p>
-            <a:pPr marL="0" lvl="0" indent="0" algn="l" rtl="0">
-              <a:spcBef>
-                <a:spcPts val="0"/>
-              </a:spcBef>
-              <a:spcAft>
-                <a:spcPts val="0"/>
-              </a:spcAft>
-              <a:buNone/>
-            </a:pPr>
-            <a:r>
-              <a:rPr lang="en-US" dirty="0"/>
-              <a:t>What Makes This Project Different?</a:t>
-            </a:r>
-            <a:endParaRPr dirty="0"/>
-          </a:p>
-        </p:txBody>
-      </p:sp>
-      <p:sp>
-        <p:nvSpPr>
-          <p:cNvPr id="74" name="Google Shape;74;p16">
-            <a:extLst>
-              <a:ext uri="{FF2B5EF4-FFF2-40B4-BE49-F238E27FC236}">
-                <a16:creationId xmlns:a16="http://schemas.microsoft.com/office/drawing/2014/main" id="{85CC995F-BB81-4BC6-9A27-DF1F2A5FFEE0}"/>
-              </a:ext>
-            </a:extLst>
-          </p:cNvPr>
-          <p:cNvSpPr txBox="1">
-            <a:spLocks noGrp="1"/>
-          </p:cNvSpPr>
-          <p:nvPr>
-            <p:ph type="body" idx="1"/>
-          </p:nvPr>
-        </p:nvSpPr>
-        <p:spPr>
-          <a:xfrm>
-            <a:off x="311700" y="1152475"/>
-            <a:ext cx="8520600" cy="3416400"/>
-          </a:xfrm>
-          <a:prstGeom prst="rect">
-            <a:avLst/>
-          </a:prstGeom>
-        </p:spPr>
-        <p:txBody>
-          <a:bodyPr spcFirstLastPara="1" wrap="square" lIns="91425" tIns="91425" rIns="91425" bIns="91425" anchor="t" anchorCtr="0">
-            <a:noAutofit/>
-          </a:bodyPr>
-          <a:lstStyle/>
-          <a:p>
-            <a:pPr marL="0" lvl="0" indent="0" algn="l" rtl="0">
-              <a:spcBef>
-                <a:spcPts val="0"/>
-              </a:spcBef>
-              <a:spcAft>
-                <a:spcPts val="1600"/>
-              </a:spcAft>
-              <a:buNone/>
-            </a:pPr>
-            <a:r>
-              <a:rPr lang="en-US" dirty="0"/>
-              <a:t>Full analytics engine with streak calculation, weekly completion %, and date range filtering</a:t>
-            </a:r>
-          </a:p>
-          <a:p>
-            <a:pPr marL="0" lvl="0" indent="0" algn="l" rtl="0">
-              <a:spcBef>
-                <a:spcPts val="0"/>
-              </a:spcBef>
-              <a:spcAft>
-                <a:spcPts val="1600"/>
-              </a:spcAft>
-              <a:buNone/>
-            </a:pPr>
-            <a:r>
-              <a:rPr lang="en-US" dirty="0"/>
-              <a:t>3 MongoDB collections with full CRUD split between both team members</a:t>
-            </a:r>
-          </a:p>
-          <a:p>
-            <a:pPr marL="0" lvl="0" indent="0" algn="l" rtl="0">
-              <a:spcBef>
-                <a:spcPts val="0"/>
-              </a:spcBef>
-              <a:spcAft>
-                <a:spcPts val="1600"/>
-              </a:spcAft>
-              <a:buNone/>
-            </a:pPr>
-            <a:r>
-              <a:rPr lang="en-US" dirty="0"/>
-              <a:t>2046 synthetic records with realistic streak patterns, duplicate prevention and batch seeding</a:t>
-            </a:r>
-          </a:p>
-        </p:txBody>
-      </p:sp>
-    </p:spTree>
-    <p:extLst>
-      <p:ext uri="{BB962C8B-B14F-4D97-AF65-F5344CB8AC3E}">
-        <p14:creationId xmlns:p14="http://schemas.microsoft.com/office/powerpoint/2010/main" val="490821702"/>
-      </p:ext>
-    </p:extLst>
   </p:cSld>
   <p:clrMapOvr>
     <a:masterClrMapping/>

</xml_diff>